<commit_message>
Removed an unimportant section
</commit_message>
<xml_diff>
--- a/EGX30_Presentation_Final.pptx
+++ b/EGX30_Presentation_Final.pptx
@@ -5,7 +5,7 @@
     <p:sldMasterId id="2147483648" r:id="rId1"/>
   </p:sldMasterIdLst>
   <p:notesMasterIdLst>
-    <p:notesMasterId r:id="rId12"/>
+    <p:notesMasterId r:id="rId11"/>
   </p:notesMasterIdLst>
   <p:sldIdLst>
     <p:sldId id="256" r:id="rId2"/>
@@ -16,8 +16,7 @@
     <p:sldId id="261" r:id="rId7"/>
     <p:sldId id="262" r:id="rId8"/>
     <p:sldId id="263" r:id="rId9"/>
-    <p:sldId id="264" r:id="rId10"/>
-    <p:sldId id="265" r:id="rId11"/>
+    <p:sldId id="265" r:id="rId10"/>
   </p:sldIdLst>
   <p:sldSz cx="9144000" cy="5143500" type="screen16x9"/>
   <p:notesSz cx="5143500" cy="9144000"/>
@@ -312,90 +311,6 @@
             <a:fld id="{F7021451-1387-4CA6-816F-3879F97B5CBC}" type="slidenum">
               <a:rPr lang="en-US"/>
               <a:t>1</a:t>
-            </a:fld>
-            <a:endParaRPr lang="en-US"/>
-          </a:p>
-        </p:txBody>
-      </p:sp>
-    </p:spTree>
-    <p:extLst>
-      <p:ext uri="{BB962C8B-B14F-4D97-AF65-F5344CB8AC3E}">
-        <p14:creationId xmlns:p14="http://schemas.microsoft.com/office/powerpoint/2010/main" val="1024086991"/>
-      </p:ext>
-    </p:extLst>
-  </p:cSld>
-  <p:clrMapOvr>
-    <a:masterClrMapping/>
-  </p:clrMapOvr>
-</p:notes>
-</file>
-
-<file path=ppt/notesSlides/notesSlide10.xml><?xml version="1.0" encoding="utf-8"?>
-<p:notes xmlns:a="http://schemas.openxmlformats.org/drawingml/2006/main" xmlns:r="http://schemas.openxmlformats.org/officeDocument/2006/relationships" xmlns:p="http://schemas.openxmlformats.org/presentationml/2006/main">
-  <p:cSld>
-    <p:spTree>
-      <p:nvGrpSpPr>
-        <p:cNvPr id="1" name=""/>
-        <p:cNvGrpSpPr/>
-        <p:nvPr/>
-      </p:nvGrpSpPr>
-      <p:grpSpPr>
-        <a:xfrm>
-          <a:off x="0" y="0"/>
-          <a:ext cx="0" cy="0"/>
-          <a:chOff x="0" y="0"/>
-          <a:chExt cx="0" cy="0"/>
-        </a:xfrm>
-      </p:grpSpPr>
-      <p:sp>
-        <p:nvSpPr>
-          <p:cNvPr id="2" name="Slide Image Placeholder 1"/>
-          <p:cNvSpPr>
-            <a:spLocks noGrp="1" noRot="1" noChangeAspect="1"/>
-          </p:cNvSpPr>
-          <p:nvPr>
-            <p:ph type="sldImg"/>
-          </p:nvPr>
-        </p:nvSpPr>
-        <p:spPr/>
-      </p:sp>
-      <p:sp>
-        <p:nvSpPr>
-          <p:cNvPr id="3" name="Notes Placeholder 2"/>
-          <p:cNvSpPr>
-            <a:spLocks noGrp="1"/>
-          </p:cNvSpPr>
-          <p:nvPr>
-            <p:ph type="body" idx="1"/>
-          </p:nvPr>
-        </p:nvSpPr>
-        <p:spPr/>
-        <p:txBody>
-          <a:bodyPr/>
-          <a:lstStyle/>
-          <a:p>
-            <a:endParaRPr lang="en-US" dirty="0"/>
-          </a:p>
-        </p:txBody>
-      </p:sp>
-      <p:sp>
-        <p:nvSpPr>
-          <p:cNvPr id="4" name="Slide Number Placeholder 3"/>
-          <p:cNvSpPr>
-            <a:spLocks noGrp="1"/>
-          </p:cNvSpPr>
-          <p:nvPr>
-            <p:ph type="sldNum" sz="quarter" idx="10"/>
-          </p:nvPr>
-        </p:nvSpPr>
-        <p:spPr/>
-        <p:txBody>
-          <a:bodyPr/>
-          <a:lstStyle/>
-          <a:p>
-            <a:fld id="{F7021451-1387-4CA6-816F-3879F97B5CBC}" type="slidenum">
-              <a:rPr lang="en-US"/>
-              <a:t>10</a:t>
             </a:fld>
             <a:endParaRPr lang="en-US"/>
           </a:p>
@@ -1512,7 +1427,7 @@
                 <a:ea typeface="Trebuchet MS" pitchFamily="34" charset="-122"/>
                 <a:cs typeface="Trebuchet MS" pitchFamily="34" charset="-120"/>
               </a:rPr>
-              <a:t>Predictive Analysis of</a:t>
+              <a:t>Data Analysis of</a:t>
             </a:r>
             <a:endParaRPr lang="en-US" sz="2000" dirty="0"/>
           </a:p>
@@ -1710,940 +1625,6 @@
               <a:t>Egypt University of Informatics - Data Analysis - Spring 2026</a:t>
             </a:r>
             <a:endParaRPr lang="en-US" sz="1000" dirty="0"/>
-          </a:p>
-        </p:txBody>
-      </p:sp>
-    </p:spTree>
-  </p:cSld>
-  <p:clrMapOvr>
-    <a:masterClrMapping/>
-  </p:clrMapOvr>
-</p:sld>
-</file>
-
-<file path=ppt/slides/slide10.xml><?xml version="1.0" encoding="utf-8"?>
-<p:sld xmlns:a="http://schemas.openxmlformats.org/drawingml/2006/main" xmlns:r="http://schemas.openxmlformats.org/officeDocument/2006/relationships" xmlns:p="http://schemas.openxmlformats.org/presentationml/2006/main">
-  <p:cSld name="Slide 10">
-    <p:bg>
-      <p:bgPr>
-        <a:solidFill>
-          <a:srgbClr val="0A1628"/>
-        </a:solidFill>
-        <a:effectLst/>
-      </p:bgPr>
-    </p:bg>
-    <p:spTree>
-      <p:nvGrpSpPr>
-        <p:cNvPr id="1" name=""/>
-        <p:cNvGrpSpPr/>
-        <p:nvPr/>
-      </p:nvGrpSpPr>
-      <p:grpSpPr>
-        <a:xfrm>
-          <a:off x="0" y="0"/>
-          <a:ext cx="0" cy="0"/>
-          <a:chOff x="0" y="0"/>
-          <a:chExt cx="0" cy="0"/>
-        </a:xfrm>
-      </p:grpSpPr>
-      <p:sp>
-        <p:nvSpPr>
-          <p:cNvPr id="2" name="Shape 0"/>
-          <p:cNvSpPr/>
-          <p:nvPr/>
-        </p:nvSpPr>
-        <p:spPr>
-          <a:xfrm>
-            <a:off x="0" y="0"/>
-            <a:ext cx="9144000" cy="54864"/>
-          </a:xfrm>
-          <a:prstGeom prst="rect">
-            <a:avLst/>
-          </a:prstGeom>
-          <a:solidFill>
-            <a:srgbClr val="22D3EE"/>
-          </a:solidFill>
-          <a:ln/>
-        </p:spPr>
-        <p:txBody>
-          <a:bodyPr/>
-          <a:lstStyle/>
-          <a:p>
-            <a:endParaRPr lang="en-GB"/>
-          </a:p>
-        </p:txBody>
-      </p:sp>
-      <p:sp>
-        <p:nvSpPr>
-          <p:cNvPr id="3" name="Text 1"/>
-          <p:cNvSpPr/>
-          <p:nvPr/>
-        </p:nvSpPr>
-        <p:spPr>
-          <a:xfrm>
-            <a:off x="457200" y="228600"/>
-            <a:ext cx="8229600" cy="457200"/>
-          </a:xfrm>
-          <a:prstGeom prst="rect">
-            <a:avLst/>
-          </a:prstGeom>
-          <a:noFill/>
-          <a:ln/>
-        </p:spPr>
-        <p:txBody>
-          <a:bodyPr wrap="square" lIns="0" tIns="0" rIns="0" bIns="0" rtlCol="0" anchor="ctr"/>
-          <a:lstStyle/>
-          <a:p>
-            <a:pPr marL="0" indent="0">
-              <a:buNone/>
-            </a:pPr>
-            <a:r>
-              <a:rPr lang="en-US" sz="2600" b="1" dirty="0">
-                <a:solidFill>
-                  <a:srgbClr val="FFFFFF"/>
-                </a:solidFill>
-                <a:latin typeface="Trebuchet MS" pitchFamily="34" charset="0"/>
-                <a:ea typeface="Trebuchet MS" pitchFamily="34" charset="-122"/>
-                <a:cs typeface="Trebuchet MS" pitchFamily="34" charset="-120"/>
-              </a:rPr>
-              <a:t>The Full Picture</a:t>
-            </a:r>
-            <a:endParaRPr lang="en-US" sz="2600" dirty="0"/>
-          </a:p>
-        </p:txBody>
-      </p:sp>
-      <p:sp>
-        <p:nvSpPr>
-          <p:cNvPr id="4" name="Shape 2"/>
-          <p:cNvSpPr/>
-          <p:nvPr/>
-        </p:nvSpPr>
-        <p:spPr>
-          <a:xfrm>
-            <a:off x="457200" y="868680"/>
-            <a:ext cx="8229600" cy="777240"/>
-          </a:xfrm>
-          <a:prstGeom prst="rect">
-            <a:avLst/>
-          </a:prstGeom>
-          <a:solidFill>
-            <a:srgbClr val="0D2847"/>
-          </a:solidFill>
-          <a:ln/>
-        </p:spPr>
-        <p:txBody>
-          <a:bodyPr/>
-          <a:lstStyle/>
-          <a:p>
-            <a:endParaRPr lang="en-GB"/>
-          </a:p>
-        </p:txBody>
-      </p:sp>
-      <p:sp>
-        <p:nvSpPr>
-          <p:cNvPr id="5" name="Shape 3"/>
-          <p:cNvSpPr/>
-          <p:nvPr/>
-        </p:nvSpPr>
-        <p:spPr>
-          <a:xfrm>
-            <a:off x="457200" y="868680"/>
-            <a:ext cx="54864" cy="777240"/>
-          </a:xfrm>
-          <a:prstGeom prst="rect">
-            <a:avLst/>
-          </a:prstGeom>
-          <a:solidFill>
-            <a:srgbClr val="10B981"/>
-          </a:solidFill>
-          <a:ln/>
-        </p:spPr>
-        <p:txBody>
-          <a:bodyPr/>
-          <a:lstStyle/>
-          <a:p>
-            <a:endParaRPr lang="en-GB"/>
-          </a:p>
-        </p:txBody>
-      </p:sp>
-      <p:sp>
-        <p:nvSpPr>
-          <p:cNvPr id="6" name="Shape 4"/>
-          <p:cNvSpPr/>
-          <p:nvPr/>
-        </p:nvSpPr>
-        <p:spPr>
-          <a:xfrm>
-            <a:off x="640080" y="978408"/>
-            <a:ext cx="347472" cy="347472"/>
-          </a:xfrm>
-          <a:prstGeom prst="ellipse">
-            <a:avLst/>
-          </a:prstGeom>
-          <a:solidFill>
-            <a:srgbClr val="10B981"/>
-          </a:solidFill>
-          <a:ln/>
-        </p:spPr>
-        <p:txBody>
-          <a:bodyPr/>
-          <a:lstStyle/>
-          <a:p>
-            <a:endParaRPr lang="en-GB"/>
-          </a:p>
-        </p:txBody>
-      </p:sp>
-      <p:sp>
-        <p:nvSpPr>
-          <p:cNvPr id="7" name="Text 5"/>
-          <p:cNvSpPr/>
-          <p:nvPr/>
-        </p:nvSpPr>
-        <p:spPr>
-          <a:xfrm>
-            <a:off x="640080" y="978408"/>
-            <a:ext cx="347472" cy="347472"/>
-          </a:xfrm>
-          <a:prstGeom prst="rect">
-            <a:avLst/>
-          </a:prstGeom>
-          <a:noFill/>
-          <a:ln/>
-        </p:spPr>
-        <p:txBody>
-          <a:bodyPr wrap="square" lIns="0" tIns="0" rIns="0" bIns="0" rtlCol="0" anchor="ctr"/>
-          <a:lstStyle/>
-          <a:p>
-            <a:pPr marL="0" indent="0" algn="ctr">
-              <a:buNone/>
-            </a:pPr>
-            <a:r>
-              <a:rPr lang="en-US" sz="1500" b="1" dirty="0">
-                <a:solidFill>
-                  <a:srgbClr val="FFFFFF"/>
-                </a:solidFill>
-                <a:latin typeface="Trebuchet MS" pitchFamily="34" charset="0"/>
-                <a:ea typeface="Trebuchet MS" pitchFamily="34" charset="-122"/>
-                <a:cs typeface="Trebuchet MS" pitchFamily="34" charset="-120"/>
-              </a:rPr>
-              <a:t>1</a:t>
-            </a:r>
-            <a:endParaRPr lang="en-US" sz="1500" dirty="0"/>
-          </a:p>
-        </p:txBody>
-      </p:sp>
-      <p:sp>
-        <p:nvSpPr>
-          <p:cNvPr id="8" name="Text 6"/>
-          <p:cNvSpPr/>
-          <p:nvPr/>
-        </p:nvSpPr>
-        <p:spPr>
-          <a:xfrm>
-            <a:off x="1143000" y="932688"/>
-            <a:ext cx="7315200" cy="274320"/>
-          </a:xfrm>
-          <a:prstGeom prst="rect">
-            <a:avLst/>
-          </a:prstGeom>
-          <a:noFill/>
-          <a:ln/>
-        </p:spPr>
-        <p:txBody>
-          <a:bodyPr wrap="square" lIns="0" tIns="0" rIns="0" bIns="0" rtlCol="0" anchor="ctr"/>
-          <a:lstStyle/>
-          <a:p>
-            <a:pPr marL="0" indent="0">
-              <a:buNone/>
-            </a:pPr>
-            <a:r>
-              <a:rPr lang="en-US" sz="1400" b="1" dirty="0">
-                <a:solidFill>
-                  <a:srgbClr val="10B981"/>
-                </a:solidFill>
-                <a:latin typeface="Trebuchet MS" pitchFamily="34" charset="0"/>
-                <a:ea typeface="Trebuchet MS" pitchFamily="34" charset="-122"/>
-                <a:cs typeface="Trebuchet MS" pitchFamily="34" charset="-120"/>
-              </a:rPr>
-              <a:t>The growth is real</a:t>
-            </a:r>
-            <a:endParaRPr lang="en-US" sz="1400" dirty="0"/>
-          </a:p>
-        </p:txBody>
-      </p:sp>
-      <p:sp>
-        <p:nvSpPr>
-          <p:cNvPr id="9" name="Text 7"/>
-          <p:cNvSpPr/>
-          <p:nvPr/>
-        </p:nvSpPr>
-        <p:spPr>
-          <a:xfrm>
-            <a:off x="1143000" y="1234440"/>
-            <a:ext cx="7315200" cy="365760"/>
-          </a:xfrm>
-          <a:prstGeom prst="rect">
-            <a:avLst/>
-          </a:prstGeom>
-          <a:noFill/>
-          <a:ln/>
-        </p:spPr>
-        <p:txBody>
-          <a:bodyPr wrap="square" lIns="0" tIns="0" rIns="0" bIns="0" rtlCol="0" anchor="ctr"/>
-          <a:lstStyle/>
-          <a:p>
-            <a:pPr marL="0" indent="0">
-              <a:buNone/>
-            </a:pPr>
-            <a:r>
-              <a:rPr lang="en-US" sz="1050" dirty="0">
-                <a:solidFill>
-                  <a:srgbClr val="E2E8F0"/>
-                </a:solidFill>
-                <a:latin typeface="Calibri" pitchFamily="34" charset="0"/>
-                <a:ea typeface="Calibri" pitchFamily="34" charset="-122"/>
-                <a:cs typeface="Calibri" pitchFamily="34" charset="-120"/>
-              </a:rPr>
-              <a:t>All 5 tested stocks rejected H₀, their upward trends are statistically significant, not random luck.</a:t>
-            </a:r>
-            <a:endParaRPr lang="en-US" sz="1050" dirty="0"/>
-          </a:p>
-        </p:txBody>
-      </p:sp>
-      <p:sp>
-        <p:nvSpPr>
-          <p:cNvPr id="10" name="Shape 8"/>
-          <p:cNvSpPr/>
-          <p:nvPr/>
-        </p:nvSpPr>
-        <p:spPr>
-          <a:xfrm>
-            <a:off x="457200" y="1783080"/>
-            <a:ext cx="8229600" cy="777240"/>
-          </a:xfrm>
-          <a:prstGeom prst="rect">
-            <a:avLst/>
-          </a:prstGeom>
-          <a:solidFill>
-            <a:srgbClr val="0D2847"/>
-          </a:solidFill>
-          <a:ln/>
-        </p:spPr>
-        <p:txBody>
-          <a:bodyPr/>
-          <a:lstStyle/>
-          <a:p>
-            <a:endParaRPr lang="en-GB"/>
-          </a:p>
-        </p:txBody>
-      </p:sp>
-      <p:sp>
-        <p:nvSpPr>
-          <p:cNvPr id="11" name="Shape 9"/>
-          <p:cNvSpPr/>
-          <p:nvPr/>
-        </p:nvSpPr>
-        <p:spPr>
-          <a:xfrm>
-            <a:off x="457200" y="1783080"/>
-            <a:ext cx="54864" cy="777240"/>
-          </a:xfrm>
-          <a:prstGeom prst="rect">
-            <a:avLst/>
-          </a:prstGeom>
-          <a:solidFill>
-            <a:srgbClr val="0891B2"/>
-          </a:solidFill>
-          <a:ln/>
-        </p:spPr>
-        <p:txBody>
-          <a:bodyPr/>
-          <a:lstStyle/>
-          <a:p>
-            <a:endParaRPr lang="en-GB"/>
-          </a:p>
-        </p:txBody>
-      </p:sp>
-      <p:sp>
-        <p:nvSpPr>
-          <p:cNvPr id="12" name="Shape 10"/>
-          <p:cNvSpPr/>
-          <p:nvPr/>
-        </p:nvSpPr>
-        <p:spPr>
-          <a:xfrm>
-            <a:off x="640080" y="1892808"/>
-            <a:ext cx="347472" cy="347472"/>
-          </a:xfrm>
-          <a:prstGeom prst="ellipse">
-            <a:avLst/>
-          </a:prstGeom>
-          <a:solidFill>
-            <a:srgbClr val="0891B2"/>
-          </a:solidFill>
-          <a:ln/>
-        </p:spPr>
-        <p:txBody>
-          <a:bodyPr/>
-          <a:lstStyle/>
-          <a:p>
-            <a:endParaRPr lang="en-GB"/>
-          </a:p>
-        </p:txBody>
-      </p:sp>
-      <p:sp>
-        <p:nvSpPr>
-          <p:cNvPr id="13" name="Text 11"/>
-          <p:cNvSpPr/>
-          <p:nvPr/>
-        </p:nvSpPr>
-        <p:spPr>
-          <a:xfrm>
-            <a:off x="640080" y="1892808"/>
-            <a:ext cx="347472" cy="347472"/>
-          </a:xfrm>
-          <a:prstGeom prst="rect">
-            <a:avLst/>
-          </a:prstGeom>
-          <a:noFill/>
-          <a:ln/>
-        </p:spPr>
-        <p:txBody>
-          <a:bodyPr wrap="square" lIns="0" tIns="0" rIns="0" bIns="0" rtlCol="0" anchor="ctr"/>
-          <a:lstStyle/>
-          <a:p>
-            <a:pPr marL="0" indent="0" algn="ctr">
-              <a:buNone/>
-            </a:pPr>
-            <a:r>
-              <a:rPr lang="en-US" sz="1500" b="1" dirty="0">
-                <a:solidFill>
-                  <a:srgbClr val="FFFFFF"/>
-                </a:solidFill>
-                <a:latin typeface="Trebuchet MS" pitchFamily="34" charset="0"/>
-                <a:ea typeface="Trebuchet MS" pitchFamily="34" charset="-122"/>
-                <a:cs typeface="Trebuchet MS" pitchFamily="34" charset="-120"/>
-              </a:rPr>
-              <a:t>2</a:t>
-            </a:r>
-            <a:endParaRPr lang="en-US" sz="1500" dirty="0"/>
-          </a:p>
-        </p:txBody>
-      </p:sp>
-      <p:sp>
-        <p:nvSpPr>
-          <p:cNvPr id="14" name="Text 12"/>
-          <p:cNvSpPr/>
-          <p:nvPr/>
-        </p:nvSpPr>
-        <p:spPr>
-          <a:xfrm>
-            <a:off x="1143000" y="1847088"/>
-            <a:ext cx="7315200" cy="274320"/>
-          </a:xfrm>
-          <a:prstGeom prst="rect">
-            <a:avLst/>
-          </a:prstGeom>
-          <a:noFill/>
-          <a:ln/>
-        </p:spPr>
-        <p:txBody>
-          <a:bodyPr wrap="square" lIns="0" tIns="0" rIns="0" bIns="0" rtlCol="0" anchor="ctr"/>
-          <a:lstStyle/>
-          <a:p>
-            <a:pPr marL="0" indent="0">
-              <a:buNone/>
-            </a:pPr>
-            <a:r>
-              <a:rPr lang="en-US" sz="1400" b="1" dirty="0">
-                <a:solidFill>
-                  <a:srgbClr val="0891B2"/>
-                </a:solidFill>
-                <a:latin typeface="Trebuchet MS" pitchFamily="34" charset="0"/>
-                <a:ea typeface="Trebuchet MS" pitchFamily="34" charset="-122"/>
-                <a:cs typeface="Trebuchet MS" pitchFamily="34" charset="-120"/>
-              </a:rPr>
-              <a:t>The whole market moves together</a:t>
-            </a:r>
-            <a:endParaRPr lang="en-US" sz="1400" dirty="0"/>
-          </a:p>
-        </p:txBody>
-      </p:sp>
-      <p:sp>
-        <p:nvSpPr>
-          <p:cNvPr id="15" name="Text 13"/>
-          <p:cNvSpPr/>
-          <p:nvPr/>
-        </p:nvSpPr>
-        <p:spPr>
-          <a:xfrm>
-            <a:off x="1143000" y="2148840"/>
-            <a:ext cx="7315200" cy="365760"/>
-          </a:xfrm>
-          <a:prstGeom prst="rect">
-            <a:avLst/>
-          </a:prstGeom>
-          <a:noFill/>
-          <a:ln/>
-        </p:spPr>
-        <p:txBody>
-          <a:bodyPr wrap="square" lIns="0" tIns="0" rIns="0" bIns="0" rtlCol="0" anchor="ctr"/>
-          <a:lstStyle/>
-          <a:p>
-            <a:pPr marL="0" indent="0">
-              <a:buNone/>
-            </a:pPr>
-            <a:r>
-              <a:rPr lang="en-US" sz="1050" dirty="0">
-                <a:solidFill>
-                  <a:srgbClr val="E2E8F0"/>
-                </a:solidFill>
-                <a:latin typeface="Calibri" pitchFamily="34" charset="0"/>
-                <a:ea typeface="Calibri" pitchFamily="34" charset="-122"/>
-                <a:cs typeface="Calibri" pitchFamily="34" charset="-120"/>
-              </a:rPr>
-              <a:t>No significant difference between sectors. When the Central Bank moves or the pound drops, every sector feels it equally.</a:t>
-            </a:r>
-            <a:endParaRPr lang="en-US" sz="1050" dirty="0"/>
-          </a:p>
-        </p:txBody>
-      </p:sp>
-      <p:sp>
-        <p:nvSpPr>
-          <p:cNvPr id="16" name="Shape 14"/>
-          <p:cNvSpPr/>
-          <p:nvPr/>
-        </p:nvSpPr>
-        <p:spPr>
-          <a:xfrm>
-            <a:off x="457200" y="2697480"/>
-            <a:ext cx="8229600" cy="777240"/>
-          </a:xfrm>
-          <a:prstGeom prst="rect">
-            <a:avLst/>
-          </a:prstGeom>
-          <a:solidFill>
-            <a:srgbClr val="0D2847"/>
-          </a:solidFill>
-          <a:ln/>
-        </p:spPr>
-        <p:txBody>
-          <a:bodyPr/>
-          <a:lstStyle/>
-          <a:p>
-            <a:endParaRPr lang="en-GB"/>
-          </a:p>
-        </p:txBody>
-      </p:sp>
-      <p:sp>
-        <p:nvSpPr>
-          <p:cNvPr id="17" name="Shape 15"/>
-          <p:cNvSpPr/>
-          <p:nvPr/>
-        </p:nvSpPr>
-        <p:spPr>
-          <a:xfrm>
-            <a:off x="457200" y="2697480"/>
-            <a:ext cx="54864" cy="777240"/>
-          </a:xfrm>
-          <a:prstGeom prst="rect">
-            <a:avLst/>
-          </a:prstGeom>
-          <a:solidFill>
-            <a:srgbClr val="EF4444"/>
-          </a:solidFill>
-          <a:ln/>
-        </p:spPr>
-        <p:txBody>
-          <a:bodyPr/>
-          <a:lstStyle/>
-          <a:p>
-            <a:endParaRPr lang="en-GB"/>
-          </a:p>
-        </p:txBody>
-      </p:sp>
-      <p:sp>
-        <p:nvSpPr>
-          <p:cNvPr id="18" name="Shape 16"/>
-          <p:cNvSpPr/>
-          <p:nvPr/>
-        </p:nvSpPr>
-        <p:spPr>
-          <a:xfrm>
-            <a:off x="640080" y="2807208"/>
-            <a:ext cx="347472" cy="347472"/>
-          </a:xfrm>
-          <a:prstGeom prst="ellipse">
-            <a:avLst/>
-          </a:prstGeom>
-          <a:solidFill>
-            <a:srgbClr val="EF4444"/>
-          </a:solidFill>
-          <a:ln/>
-        </p:spPr>
-        <p:txBody>
-          <a:bodyPr/>
-          <a:lstStyle/>
-          <a:p>
-            <a:endParaRPr lang="en-GB"/>
-          </a:p>
-        </p:txBody>
-      </p:sp>
-      <p:sp>
-        <p:nvSpPr>
-          <p:cNvPr id="19" name="Text 17"/>
-          <p:cNvSpPr/>
-          <p:nvPr/>
-        </p:nvSpPr>
-        <p:spPr>
-          <a:xfrm>
-            <a:off x="640080" y="2807208"/>
-            <a:ext cx="347472" cy="347472"/>
-          </a:xfrm>
-          <a:prstGeom prst="rect">
-            <a:avLst/>
-          </a:prstGeom>
-          <a:noFill/>
-          <a:ln/>
-        </p:spPr>
-        <p:txBody>
-          <a:bodyPr wrap="square" lIns="0" tIns="0" rIns="0" bIns="0" rtlCol="0" anchor="ctr"/>
-          <a:lstStyle/>
-          <a:p>
-            <a:pPr marL="0" indent="0" algn="ctr">
-              <a:buNone/>
-            </a:pPr>
-            <a:r>
-              <a:rPr lang="en-US" sz="1500" b="1" dirty="0">
-                <a:solidFill>
-                  <a:srgbClr val="FFFFFF"/>
-                </a:solidFill>
-                <a:latin typeface="Trebuchet MS" pitchFamily="34" charset="0"/>
-                <a:ea typeface="Trebuchet MS" pitchFamily="34" charset="-122"/>
-                <a:cs typeface="Trebuchet MS" pitchFamily="34" charset="-120"/>
-              </a:rPr>
-              <a:t>3</a:t>
-            </a:r>
-            <a:endParaRPr lang="en-US" sz="1500" dirty="0"/>
-          </a:p>
-        </p:txBody>
-      </p:sp>
-      <p:sp>
-        <p:nvSpPr>
-          <p:cNvPr id="20" name="Text 18"/>
-          <p:cNvSpPr/>
-          <p:nvPr/>
-        </p:nvSpPr>
-        <p:spPr>
-          <a:xfrm>
-            <a:off x="1143000" y="2761488"/>
-            <a:ext cx="7315200" cy="274320"/>
-          </a:xfrm>
-          <a:prstGeom prst="rect">
-            <a:avLst/>
-          </a:prstGeom>
-          <a:noFill/>
-          <a:ln/>
-        </p:spPr>
-        <p:txBody>
-          <a:bodyPr wrap="square" lIns="0" tIns="0" rIns="0" bIns="0" rtlCol="0" anchor="ctr"/>
-          <a:lstStyle/>
-          <a:p>
-            <a:pPr marL="0" indent="0">
-              <a:buNone/>
-            </a:pPr>
-            <a:r>
-              <a:rPr lang="en-US" sz="1400" b="1" dirty="0">
-                <a:solidFill>
-                  <a:srgbClr val="EF4444"/>
-                </a:solidFill>
-                <a:latin typeface="Trebuchet MS" pitchFamily="34" charset="0"/>
-                <a:ea typeface="Trebuchet MS" pitchFamily="34" charset="-122"/>
-                <a:cs typeface="Trebuchet MS" pitchFamily="34" charset="-120"/>
-              </a:rPr>
-              <a:t>Devaluations hit everyone</a:t>
-            </a:r>
-            <a:endParaRPr lang="en-US" sz="1400" dirty="0"/>
-          </a:p>
-        </p:txBody>
-      </p:sp>
-      <p:sp>
-        <p:nvSpPr>
-          <p:cNvPr id="21" name="Text 19"/>
-          <p:cNvSpPr/>
-          <p:nvPr/>
-        </p:nvSpPr>
-        <p:spPr>
-          <a:xfrm>
-            <a:off x="1143000" y="3063240"/>
-            <a:ext cx="7315200" cy="365760"/>
-          </a:xfrm>
-          <a:prstGeom prst="rect">
-            <a:avLst/>
-          </a:prstGeom>
-          <a:noFill/>
-          <a:ln/>
-        </p:spPr>
-        <p:txBody>
-          <a:bodyPr wrap="square" lIns="0" tIns="0" rIns="0" bIns="0" rtlCol="0" anchor="ctr"/>
-          <a:lstStyle/>
-          <a:p>
-            <a:pPr marL="0" indent="0">
-              <a:buNone/>
-            </a:pPr>
-            <a:r>
-              <a:rPr lang="en-US" sz="1050" dirty="0">
-                <a:solidFill>
-                  <a:srgbClr val="E2E8F0"/>
-                </a:solidFill>
-                <a:latin typeface="Calibri" pitchFamily="34" charset="0"/>
-                <a:ea typeface="Calibri" pitchFamily="34" charset="-122"/>
-                <a:cs typeface="Calibri" pitchFamily="34" charset="-120"/>
-              </a:rPr>
-              <a:t>All three EGP devaluations caused volatility spikes across all stocks. Jan 2024 was the biggest shock — daily swings doubled overnight.</a:t>
-            </a:r>
-            <a:endParaRPr lang="en-US" sz="1050" dirty="0"/>
-          </a:p>
-        </p:txBody>
-      </p:sp>
-      <p:sp>
-        <p:nvSpPr>
-          <p:cNvPr id="22" name="Shape 20"/>
-          <p:cNvSpPr/>
-          <p:nvPr/>
-        </p:nvSpPr>
-        <p:spPr>
-          <a:xfrm>
-            <a:off x="457200" y="3611880"/>
-            <a:ext cx="8229600" cy="777240"/>
-          </a:xfrm>
-          <a:prstGeom prst="rect">
-            <a:avLst/>
-          </a:prstGeom>
-          <a:solidFill>
-            <a:srgbClr val="0D2847"/>
-          </a:solidFill>
-          <a:ln/>
-        </p:spPr>
-        <p:txBody>
-          <a:bodyPr/>
-          <a:lstStyle/>
-          <a:p>
-            <a:endParaRPr lang="en-GB"/>
-          </a:p>
-        </p:txBody>
-      </p:sp>
-      <p:sp>
-        <p:nvSpPr>
-          <p:cNvPr id="23" name="Shape 21"/>
-          <p:cNvSpPr/>
-          <p:nvPr/>
-        </p:nvSpPr>
-        <p:spPr>
-          <a:xfrm>
-            <a:off x="457200" y="3611880"/>
-            <a:ext cx="54864" cy="777240"/>
-          </a:xfrm>
-          <a:prstGeom prst="rect">
-            <a:avLst/>
-          </a:prstGeom>
-          <a:solidFill>
-            <a:srgbClr val="F59E0B"/>
-          </a:solidFill>
-          <a:ln/>
-        </p:spPr>
-        <p:txBody>
-          <a:bodyPr/>
-          <a:lstStyle/>
-          <a:p>
-            <a:endParaRPr lang="en-GB"/>
-          </a:p>
-        </p:txBody>
-      </p:sp>
-      <p:sp>
-        <p:nvSpPr>
-          <p:cNvPr id="24" name="Shape 22"/>
-          <p:cNvSpPr/>
-          <p:nvPr/>
-        </p:nvSpPr>
-        <p:spPr>
-          <a:xfrm>
-            <a:off x="640080" y="3721608"/>
-            <a:ext cx="347472" cy="347472"/>
-          </a:xfrm>
-          <a:prstGeom prst="ellipse">
-            <a:avLst/>
-          </a:prstGeom>
-          <a:solidFill>
-            <a:srgbClr val="F59E0B"/>
-          </a:solidFill>
-          <a:ln/>
-        </p:spPr>
-        <p:txBody>
-          <a:bodyPr/>
-          <a:lstStyle/>
-          <a:p>
-            <a:endParaRPr lang="en-GB"/>
-          </a:p>
-        </p:txBody>
-      </p:sp>
-      <p:sp>
-        <p:nvSpPr>
-          <p:cNvPr id="25" name="Text 23"/>
-          <p:cNvSpPr/>
-          <p:nvPr/>
-        </p:nvSpPr>
-        <p:spPr>
-          <a:xfrm>
-            <a:off x="640080" y="3721608"/>
-            <a:ext cx="347472" cy="347472"/>
-          </a:xfrm>
-          <a:prstGeom prst="rect">
-            <a:avLst/>
-          </a:prstGeom>
-          <a:noFill/>
-          <a:ln/>
-        </p:spPr>
-        <p:txBody>
-          <a:bodyPr wrap="square" lIns="0" tIns="0" rIns="0" bIns="0" rtlCol="0" anchor="ctr"/>
-          <a:lstStyle/>
-          <a:p>
-            <a:pPr marL="0" indent="0" algn="ctr">
-              <a:buNone/>
-            </a:pPr>
-            <a:r>
-              <a:rPr lang="en-US" sz="1500" b="1" dirty="0">
-                <a:solidFill>
-                  <a:srgbClr val="FFFFFF"/>
-                </a:solidFill>
-                <a:latin typeface="Trebuchet MS" pitchFamily="34" charset="0"/>
-                <a:ea typeface="Trebuchet MS" pitchFamily="34" charset="-122"/>
-                <a:cs typeface="Trebuchet MS" pitchFamily="34" charset="-120"/>
-              </a:rPr>
-              <a:t>4</a:t>
-            </a:r>
-            <a:endParaRPr lang="en-US" sz="1500" dirty="0"/>
-          </a:p>
-        </p:txBody>
-      </p:sp>
-      <p:sp>
-        <p:nvSpPr>
-          <p:cNvPr id="26" name="Text 24"/>
-          <p:cNvSpPr/>
-          <p:nvPr/>
-        </p:nvSpPr>
-        <p:spPr>
-          <a:xfrm>
-            <a:off x="1143000" y="3675888"/>
-            <a:ext cx="7315200" cy="274320"/>
-          </a:xfrm>
-          <a:prstGeom prst="rect">
-            <a:avLst/>
-          </a:prstGeom>
-          <a:noFill/>
-          <a:ln/>
-        </p:spPr>
-        <p:txBody>
-          <a:bodyPr wrap="square" lIns="0" tIns="0" rIns="0" bIns="0" rtlCol="0" anchor="ctr"/>
-          <a:lstStyle/>
-          <a:p>
-            <a:pPr marL="0" indent="0">
-              <a:buNone/>
-            </a:pPr>
-            <a:r>
-              <a:rPr lang="en-US" sz="1400" b="1" dirty="0">
-                <a:solidFill>
-                  <a:srgbClr val="F59E0B"/>
-                </a:solidFill>
-                <a:latin typeface="Trebuchet MS" pitchFamily="34" charset="0"/>
-                <a:ea typeface="Trebuchet MS" pitchFamily="34" charset="-122"/>
-                <a:cs typeface="Trebuchet MS" pitchFamily="34" charset="-120"/>
-              </a:rPr>
-              <a:t>Prediction has limits</a:t>
-            </a:r>
-            <a:endParaRPr lang="en-US" sz="1400" dirty="0"/>
-          </a:p>
-        </p:txBody>
-      </p:sp>
-      <p:sp>
-        <p:nvSpPr>
-          <p:cNvPr id="27" name="Text 25"/>
-          <p:cNvSpPr/>
-          <p:nvPr/>
-        </p:nvSpPr>
-        <p:spPr>
-          <a:xfrm>
-            <a:off x="1143000" y="3977640"/>
-            <a:ext cx="7315200" cy="365760"/>
-          </a:xfrm>
-          <a:prstGeom prst="rect">
-            <a:avLst/>
-          </a:prstGeom>
-          <a:noFill/>
-          <a:ln/>
-        </p:spPr>
-        <p:txBody>
-          <a:bodyPr wrap="square" lIns="0" tIns="0" rIns="0" bIns="0" rtlCol="0" anchor="ctr"/>
-          <a:lstStyle/>
-          <a:p>
-            <a:pPr marL="0" indent="0">
-              <a:buNone/>
-            </a:pPr>
-            <a:r>
-              <a:rPr lang="en-US" sz="1050" dirty="0">
-                <a:solidFill>
-                  <a:srgbClr val="E2E8F0"/>
-                </a:solidFill>
-                <a:latin typeface="Calibri" pitchFamily="34" charset="0"/>
-                <a:ea typeface="Calibri" pitchFamily="34" charset="-122"/>
-                <a:cs typeface="Calibri" pitchFamily="34" charset="-120"/>
-              </a:rPr>
-              <a:t>Linear regression tracks trends nicely (R² &gt; 0.97) but can't see sudden crashes coming. The model reads yesterday's newspaper.</a:t>
-            </a:r>
-            <a:endParaRPr lang="en-US" sz="1050" dirty="0"/>
-          </a:p>
-        </p:txBody>
-      </p:sp>
-      <p:sp>
-        <p:nvSpPr>
-          <p:cNvPr id="28" name="Text 26"/>
-          <p:cNvSpPr/>
-          <p:nvPr/>
-        </p:nvSpPr>
-        <p:spPr>
-          <a:xfrm>
-            <a:off x="457200" y="4498848"/>
-            <a:ext cx="8306114" cy="521208"/>
-          </a:xfrm>
-          <a:prstGeom prst="rect">
-            <a:avLst/>
-          </a:prstGeom>
-          <a:noFill/>
-          <a:ln/>
-        </p:spPr>
-        <p:txBody>
-          <a:bodyPr wrap="square" lIns="0" tIns="0" rIns="0" bIns="0" rtlCol="0" anchor="ctr"/>
-          <a:lstStyle/>
-          <a:p>
-            <a:pPr marL="0" indent="0">
-              <a:buNone/>
-            </a:pPr>
-            <a:r>
-              <a:rPr lang="en-US" sz="1000" i="1" dirty="0">
-                <a:solidFill>
-                  <a:schemeClr val="bg1"/>
-                </a:solidFill>
-                <a:latin typeface="Calibri" pitchFamily="34" charset="0"/>
-                <a:ea typeface="Calibri" pitchFamily="34" charset="-122"/>
-                <a:cs typeface="Calibri" pitchFamily="34" charset="-120"/>
-              </a:rPr>
-              <a:t>Bottom line: understanding macro events - especially currency policy - matters more than any technical indicator for navigating the Egyptian market.</a:t>
-            </a:r>
-            <a:endParaRPr lang="en-US" sz="1000" dirty="0">
-              <a:solidFill>
-                <a:schemeClr val="bg1"/>
-              </a:solidFill>
-            </a:endParaRPr>
           </a:p>
         </p:txBody>
       </p:sp>
@@ -8165,11 +7146,11 @@
 
 <file path=ppt/slides/slide9.xml><?xml version="1.0" encoding="utf-8"?>
 <p:sld xmlns:a="http://schemas.openxmlformats.org/drawingml/2006/main" xmlns:r="http://schemas.openxmlformats.org/officeDocument/2006/relationships" xmlns:p="http://schemas.openxmlformats.org/presentationml/2006/main">
-  <p:cSld name="Slide 9">
+  <p:cSld name="Slide 10">
     <p:bg>
       <p:bgPr>
         <a:solidFill>
-          <a:srgbClr val="FFFFFF"/>
+          <a:srgbClr val="0A1628"/>
         </a:solidFill>
         <a:effectLst/>
       </p:bgPr>
@@ -8203,7 +7184,7 @@
             <a:avLst/>
           </a:prstGeom>
           <a:solidFill>
-            <a:srgbClr val="0891B2"/>
+            <a:srgbClr val="22D3EE"/>
           </a:solidFill>
           <a:ln/>
         </p:spPr>
@@ -8223,7 +7204,7 @@
         </p:nvSpPr>
         <p:spPr>
           <a:xfrm>
-            <a:off x="457200" y="182880"/>
+            <a:off x="457200" y="228600"/>
             <a:ext cx="8229600" cy="457200"/>
           </a:xfrm>
           <a:prstGeom prst="rect">
@@ -8240,93 +7221,38 @@
               <a:buNone/>
             </a:pPr>
             <a:r>
-              <a:rPr lang="en-US" sz="2400" b="1" dirty="0">
-                <a:solidFill>
-                  <a:srgbClr val="1E293B"/>
+              <a:rPr lang="en-US" sz="2600" b="1" dirty="0">
+                <a:solidFill>
+                  <a:srgbClr val="FFFFFF"/>
                 </a:solidFill>
                 <a:latin typeface="Trebuchet MS" pitchFamily="34" charset="0"/>
                 <a:ea typeface="Trebuchet MS" pitchFamily="34" charset="-122"/>
                 <a:cs typeface="Trebuchet MS" pitchFamily="34" charset="-120"/>
               </a:rPr>
-              <a:t>Can We Predict Tomorrow's Price?</a:t>
-            </a:r>
-            <a:endParaRPr lang="en-US" sz="2400" dirty="0"/>
-          </a:p>
-        </p:txBody>
-      </p:sp>
-      <p:pic>
-        <p:nvPicPr>
-          <p:cNvPr id="4" name="Image 0" descr="preencoded.png"/>
-          <p:cNvPicPr>
-            <a:picLocks noChangeAspect="1"/>
-          </p:cNvPicPr>
-          <p:nvPr/>
-        </p:nvPicPr>
-        <p:blipFill>
-          <a:blip r:embed="rId3"/>
-          <a:stretch>
-            <a:fillRect/>
-          </a:stretch>
-        </p:blipFill>
-        <p:spPr>
-          <a:xfrm>
-            <a:off x="91440" y="685800"/>
-            <a:ext cx="8961120" cy="1920240"/>
-          </a:xfrm>
-          <a:prstGeom prst="rect">
-            <a:avLst/>
-          </a:prstGeom>
-        </p:spPr>
-      </p:pic>
-      <p:pic>
-        <p:nvPicPr>
-          <p:cNvPr id="5" name="Image 1" descr="preencoded.png"/>
-          <p:cNvPicPr>
-            <a:picLocks noChangeAspect="1"/>
-          </p:cNvPicPr>
-          <p:nvPr/>
-        </p:nvPicPr>
-        <p:blipFill>
-          <a:blip r:embed="rId4"/>
-          <a:stretch>
-            <a:fillRect/>
-          </a:stretch>
-        </p:blipFill>
-        <p:spPr>
-          <a:xfrm>
-            <a:off x="457200" y="2697480"/>
-            <a:ext cx="5029200" cy="1645920"/>
-          </a:xfrm>
-          <a:prstGeom prst="rect">
-            <a:avLst/>
-          </a:prstGeom>
-        </p:spPr>
-      </p:pic>
-      <p:sp>
-        <p:nvSpPr>
-          <p:cNvPr id="6" name="Shape 2"/>
-          <p:cNvSpPr/>
-          <p:nvPr/>
-        </p:nvSpPr>
-        <p:spPr>
-          <a:xfrm>
-            <a:off x="5760720" y="2743200"/>
-            <a:ext cx="3108960" cy="2194560"/>
+              <a:t>The Full Picture</a:t>
+            </a:r>
+            <a:endParaRPr lang="en-US" sz="2600" dirty="0"/>
+          </a:p>
+        </p:txBody>
+      </p:sp>
+      <p:sp>
+        <p:nvSpPr>
+          <p:cNvPr id="4" name="Shape 2"/>
+          <p:cNvSpPr/>
+          <p:nvPr/>
+        </p:nvSpPr>
+        <p:spPr>
+          <a:xfrm>
+            <a:off x="457200" y="868680"/>
+            <a:ext cx="8229600" cy="777240"/>
           </a:xfrm>
           <a:prstGeom prst="rect">
             <a:avLst/>
           </a:prstGeom>
           <a:solidFill>
-            <a:srgbClr val="F0F9FF"/>
+            <a:srgbClr val="0D2847"/>
           </a:solidFill>
           <a:ln/>
-          <a:effectLst>
-            <a:outerShdw blurRad="76200" dist="25400" dir="8100000" algn="bl" rotWithShape="0">
-              <a:srgbClr val="000000">
-                <a:alpha val="12000"/>
-              </a:srgbClr>
-            </a:outerShdw>
-          </a:effectLst>
         </p:spPr>
         <p:txBody>
           <a:bodyPr/>
@@ -8338,14 +7264,68 @@
       </p:sp>
       <p:sp>
         <p:nvSpPr>
-          <p:cNvPr id="7" name="Text 3"/>
-          <p:cNvSpPr/>
-          <p:nvPr/>
-        </p:nvSpPr>
-        <p:spPr>
-          <a:xfrm>
-            <a:off x="5897880" y="2834640"/>
-            <a:ext cx="2834640" cy="274320"/>
+          <p:cNvPr id="5" name="Shape 3"/>
+          <p:cNvSpPr/>
+          <p:nvPr/>
+        </p:nvSpPr>
+        <p:spPr>
+          <a:xfrm>
+            <a:off x="457200" y="868680"/>
+            <a:ext cx="54864" cy="777240"/>
+          </a:xfrm>
+          <a:prstGeom prst="rect">
+            <a:avLst/>
+          </a:prstGeom>
+          <a:solidFill>
+            <a:srgbClr val="10B981"/>
+          </a:solidFill>
+          <a:ln/>
+        </p:spPr>
+        <p:txBody>
+          <a:bodyPr/>
+          <a:lstStyle/>
+          <a:p>
+            <a:endParaRPr lang="en-GB"/>
+          </a:p>
+        </p:txBody>
+      </p:sp>
+      <p:sp>
+        <p:nvSpPr>
+          <p:cNvPr id="6" name="Shape 4"/>
+          <p:cNvSpPr/>
+          <p:nvPr/>
+        </p:nvSpPr>
+        <p:spPr>
+          <a:xfrm>
+            <a:off x="640080" y="978408"/>
+            <a:ext cx="347472" cy="347472"/>
+          </a:xfrm>
+          <a:prstGeom prst="ellipse">
+            <a:avLst/>
+          </a:prstGeom>
+          <a:solidFill>
+            <a:srgbClr val="10B981"/>
+          </a:solidFill>
+          <a:ln/>
+        </p:spPr>
+        <p:txBody>
+          <a:bodyPr/>
+          <a:lstStyle/>
+          <a:p>
+            <a:endParaRPr lang="en-GB"/>
+          </a:p>
+        </p:txBody>
+      </p:sp>
+      <p:sp>
+        <p:nvSpPr>
+          <p:cNvPr id="7" name="Text 5"/>
+          <p:cNvSpPr/>
+          <p:nvPr/>
+        </p:nvSpPr>
+        <p:spPr>
+          <a:xfrm>
+            <a:off x="640080" y="978408"/>
+            <a:ext cx="347472" cy="347472"/>
           </a:xfrm>
           <a:prstGeom prst="rect">
             <a:avLst/>
@@ -8357,34 +7337,34 @@
           <a:bodyPr wrap="square" lIns="0" tIns="0" rIns="0" bIns="0" rtlCol="0" anchor="ctr"/>
           <a:lstStyle/>
           <a:p>
-            <a:pPr marL="0" indent="0">
-              <a:buNone/>
-            </a:pPr>
-            <a:r>
-              <a:rPr lang="en-US" sz="1300" b="1" dirty="0">
-                <a:solidFill>
-                  <a:srgbClr val="1E293B"/>
+            <a:pPr marL="0" indent="0" algn="ctr">
+              <a:buNone/>
+            </a:pPr>
+            <a:r>
+              <a:rPr lang="en-US" sz="1500" b="1" dirty="0">
+                <a:solidFill>
+                  <a:srgbClr val="FFFFFF"/>
                 </a:solidFill>
                 <a:latin typeface="Trebuchet MS" pitchFamily="34" charset="0"/>
                 <a:ea typeface="Trebuchet MS" pitchFamily="34" charset="-122"/>
                 <a:cs typeface="Trebuchet MS" pitchFamily="34" charset="-120"/>
               </a:rPr>
-              <a:t>Honest Assessment</a:t>
-            </a:r>
-            <a:endParaRPr lang="en-US" sz="1300" dirty="0"/>
-          </a:p>
-        </p:txBody>
-      </p:sp>
-      <p:sp>
-        <p:nvSpPr>
-          <p:cNvPr id="8" name="Text 4"/>
-          <p:cNvSpPr/>
-          <p:nvPr/>
-        </p:nvSpPr>
-        <p:spPr>
-          <a:xfrm>
-            <a:off x="5897880" y="3154680"/>
-            <a:ext cx="2834640" cy="1737360"/>
+              <a:t>1</a:t>
+            </a:r>
+            <a:endParaRPr lang="en-US" sz="1500" dirty="0"/>
+          </a:p>
+        </p:txBody>
+      </p:sp>
+      <p:sp>
+        <p:nvSpPr>
+          <p:cNvPr id="8" name="Text 6"/>
+          <p:cNvSpPr/>
+          <p:nvPr/>
+        </p:nvSpPr>
+        <p:spPr>
+          <a:xfrm>
+            <a:off x="1143000" y="932688"/>
+            <a:ext cx="7315200" cy="274320"/>
           </a:xfrm>
           <a:prstGeom prst="rect">
             <a:avLst/>
@@ -8396,88 +7376,705 @@
           <a:bodyPr wrap="square" lIns="0" tIns="0" rIns="0" bIns="0" rtlCol="0" anchor="ctr"/>
           <a:lstStyle/>
           <a:p>
-            <a:pPr marL="342900" indent="-342900">
-              <a:spcAft>
-                <a:spcPts val="600"/>
-              </a:spcAft>
-              <a:buSzPct val="100000"/>
-              <a:buChar char="•"/>
-            </a:pPr>
-            <a:r>
-              <a:rPr lang="en-US" sz="950" dirty="0">
-                <a:solidFill>
-                  <a:srgbClr val="1E293B"/>
+            <a:pPr marL="0" indent="0">
+              <a:buNone/>
+            </a:pPr>
+            <a:r>
+              <a:rPr lang="en-US" sz="1400" b="1" dirty="0">
+                <a:solidFill>
+                  <a:srgbClr val="10B981"/>
+                </a:solidFill>
+                <a:latin typeface="Trebuchet MS" pitchFamily="34" charset="0"/>
+                <a:ea typeface="Trebuchet MS" pitchFamily="34" charset="-122"/>
+                <a:cs typeface="Trebuchet MS" pitchFamily="34" charset="-120"/>
+              </a:rPr>
+              <a:t>The growth is real</a:t>
+            </a:r>
+            <a:endParaRPr lang="en-US" sz="1400" dirty="0"/>
+          </a:p>
+        </p:txBody>
+      </p:sp>
+      <p:sp>
+        <p:nvSpPr>
+          <p:cNvPr id="9" name="Text 7"/>
+          <p:cNvSpPr/>
+          <p:nvPr/>
+        </p:nvSpPr>
+        <p:spPr>
+          <a:xfrm>
+            <a:off x="1143000" y="1234440"/>
+            <a:ext cx="7315200" cy="365760"/>
+          </a:xfrm>
+          <a:prstGeom prst="rect">
+            <a:avLst/>
+          </a:prstGeom>
+          <a:noFill/>
+          <a:ln/>
+        </p:spPr>
+        <p:txBody>
+          <a:bodyPr wrap="square" lIns="0" tIns="0" rIns="0" bIns="0" rtlCol="0" anchor="ctr"/>
+          <a:lstStyle/>
+          <a:p>
+            <a:pPr marL="0" indent="0">
+              <a:buNone/>
+            </a:pPr>
+            <a:r>
+              <a:rPr lang="en-US" sz="1050" dirty="0">
+                <a:solidFill>
+                  <a:srgbClr val="E2E8F0"/>
                 </a:solidFill>
                 <a:latin typeface="Calibri" pitchFamily="34" charset="0"/>
                 <a:ea typeface="Calibri" pitchFamily="34" charset="-122"/>
                 <a:cs typeface="Calibri" pitchFamily="34" charset="-120"/>
               </a:rPr>
-              <a:t>R² scores look great (0.97+), but that's partly because we use yesterday's price to predict today's</a:t>
-            </a:r>
-            <a:endParaRPr lang="en-US" sz="950" dirty="0"/>
-          </a:p>
-          <a:p>
-            <a:pPr marL="342900" indent="-342900">
-              <a:spcAft>
-                <a:spcPts val="600"/>
-              </a:spcAft>
-              <a:buSzPct val="100000"/>
-              <a:buChar char="•"/>
-            </a:pPr>
-            <a:r>
-              <a:rPr lang="en-US" sz="950" dirty="0">
-                <a:solidFill>
-                  <a:srgbClr val="1E293B"/>
+              <a:t>All 5 tested stocks rejected H₀, their upward trends are statistically significant, not random luck.</a:t>
+            </a:r>
+            <a:endParaRPr lang="en-US" sz="1050" dirty="0"/>
+          </a:p>
+        </p:txBody>
+      </p:sp>
+      <p:sp>
+        <p:nvSpPr>
+          <p:cNvPr id="10" name="Shape 8"/>
+          <p:cNvSpPr/>
+          <p:nvPr/>
+        </p:nvSpPr>
+        <p:spPr>
+          <a:xfrm>
+            <a:off x="457200" y="1783080"/>
+            <a:ext cx="8229600" cy="777240"/>
+          </a:xfrm>
+          <a:prstGeom prst="rect">
+            <a:avLst/>
+          </a:prstGeom>
+          <a:solidFill>
+            <a:srgbClr val="0D2847"/>
+          </a:solidFill>
+          <a:ln/>
+        </p:spPr>
+        <p:txBody>
+          <a:bodyPr/>
+          <a:lstStyle/>
+          <a:p>
+            <a:endParaRPr lang="en-GB"/>
+          </a:p>
+        </p:txBody>
+      </p:sp>
+      <p:sp>
+        <p:nvSpPr>
+          <p:cNvPr id="11" name="Shape 9"/>
+          <p:cNvSpPr/>
+          <p:nvPr/>
+        </p:nvSpPr>
+        <p:spPr>
+          <a:xfrm>
+            <a:off x="457200" y="1783080"/>
+            <a:ext cx="54864" cy="777240"/>
+          </a:xfrm>
+          <a:prstGeom prst="rect">
+            <a:avLst/>
+          </a:prstGeom>
+          <a:solidFill>
+            <a:srgbClr val="0891B2"/>
+          </a:solidFill>
+          <a:ln/>
+        </p:spPr>
+        <p:txBody>
+          <a:bodyPr/>
+          <a:lstStyle/>
+          <a:p>
+            <a:endParaRPr lang="en-GB"/>
+          </a:p>
+        </p:txBody>
+      </p:sp>
+      <p:sp>
+        <p:nvSpPr>
+          <p:cNvPr id="12" name="Shape 10"/>
+          <p:cNvSpPr/>
+          <p:nvPr/>
+        </p:nvSpPr>
+        <p:spPr>
+          <a:xfrm>
+            <a:off x="640080" y="1892808"/>
+            <a:ext cx="347472" cy="347472"/>
+          </a:xfrm>
+          <a:prstGeom prst="ellipse">
+            <a:avLst/>
+          </a:prstGeom>
+          <a:solidFill>
+            <a:srgbClr val="0891B2"/>
+          </a:solidFill>
+          <a:ln/>
+        </p:spPr>
+        <p:txBody>
+          <a:bodyPr/>
+          <a:lstStyle/>
+          <a:p>
+            <a:endParaRPr lang="en-GB"/>
+          </a:p>
+        </p:txBody>
+      </p:sp>
+      <p:sp>
+        <p:nvSpPr>
+          <p:cNvPr id="13" name="Text 11"/>
+          <p:cNvSpPr/>
+          <p:nvPr/>
+        </p:nvSpPr>
+        <p:spPr>
+          <a:xfrm>
+            <a:off x="640080" y="1892808"/>
+            <a:ext cx="347472" cy="347472"/>
+          </a:xfrm>
+          <a:prstGeom prst="rect">
+            <a:avLst/>
+          </a:prstGeom>
+          <a:noFill/>
+          <a:ln/>
+        </p:spPr>
+        <p:txBody>
+          <a:bodyPr wrap="square" lIns="0" tIns="0" rIns="0" bIns="0" rtlCol="0" anchor="ctr"/>
+          <a:lstStyle/>
+          <a:p>
+            <a:pPr marL="0" indent="0" algn="ctr">
+              <a:buNone/>
+            </a:pPr>
+            <a:r>
+              <a:rPr lang="en-US" sz="1500" b="1" dirty="0">
+                <a:solidFill>
+                  <a:srgbClr val="FFFFFF"/>
+                </a:solidFill>
+                <a:latin typeface="Trebuchet MS" pitchFamily="34" charset="0"/>
+                <a:ea typeface="Trebuchet MS" pitchFamily="34" charset="-122"/>
+                <a:cs typeface="Trebuchet MS" pitchFamily="34" charset="-120"/>
+              </a:rPr>
+              <a:t>2</a:t>
+            </a:r>
+            <a:endParaRPr lang="en-US" sz="1500" dirty="0"/>
+          </a:p>
+        </p:txBody>
+      </p:sp>
+      <p:sp>
+        <p:nvSpPr>
+          <p:cNvPr id="14" name="Text 12"/>
+          <p:cNvSpPr/>
+          <p:nvPr/>
+        </p:nvSpPr>
+        <p:spPr>
+          <a:xfrm>
+            <a:off x="1143000" y="1847088"/>
+            <a:ext cx="7315200" cy="274320"/>
+          </a:xfrm>
+          <a:prstGeom prst="rect">
+            <a:avLst/>
+          </a:prstGeom>
+          <a:noFill/>
+          <a:ln/>
+        </p:spPr>
+        <p:txBody>
+          <a:bodyPr wrap="square" lIns="0" tIns="0" rIns="0" bIns="0" rtlCol="0" anchor="ctr"/>
+          <a:lstStyle/>
+          <a:p>
+            <a:pPr marL="0" indent="0">
+              <a:buNone/>
+            </a:pPr>
+            <a:r>
+              <a:rPr lang="en-US" sz="1400" b="1" dirty="0">
+                <a:solidFill>
+                  <a:srgbClr val="0891B2"/>
+                </a:solidFill>
+                <a:latin typeface="Trebuchet MS" pitchFamily="34" charset="0"/>
+                <a:ea typeface="Trebuchet MS" pitchFamily="34" charset="-122"/>
+                <a:cs typeface="Trebuchet MS" pitchFamily="34" charset="-120"/>
+              </a:rPr>
+              <a:t>The whole market moves together</a:t>
+            </a:r>
+            <a:endParaRPr lang="en-US" sz="1400" dirty="0"/>
+          </a:p>
+        </p:txBody>
+      </p:sp>
+      <p:sp>
+        <p:nvSpPr>
+          <p:cNvPr id="15" name="Text 13"/>
+          <p:cNvSpPr/>
+          <p:nvPr/>
+        </p:nvSpPr>
+        <p:spPr>
+          <a:xfrm>
+            <a:off x="1143000" y="2148840"/>
+            <a:ext cx="7315200" cy="365760"/>
+          </a:xfrm>
+          <a:prstGeom prst="rect">
+            <a:avLst/>
+          </a:prstGeom>
+          <a:noFill/>
+          <a:ln/>
+        </p:spPr>
+        <p:txBody>
+          <a:bodyPr wrap="square" lIns="0" tIns="0" rIns="0" bIns="0" rtlCol="0" anchor="ctr"/>
+          <a:lstStyle/>
+          <a:p>
+            <a:pPr marL="0" indent="0">
+              <a:buNone/>
+            </a:pPr>
+            <a:r>
+              <a:rPr lang="en-US" sz="1050" dirty="0">
+                <a:solidFill>
+                  <a:srgbClr val="E2E8F0"/>
                 </a:solidFill>
                 <a:latin typeface="Calibri" pitchFamily="34" charset="0"/>
                 <a:ea typeface="Calibri" pitchFamily="34" charset="-122"/>
                 <a:cs typeface="Calibri" pitchFamily="34" charset="-120"/>
               </a:rPr>
-              <a:t>The model tracks trends well but can't predict sudden crashes from devaluation events</a:t>
-            </a:r>
-            <a:endParaRPr lang="en-US" sz="950" dirty="0"/>
-          </a:p>
-          <a:p>
-            <a:pPr marL="342900" indent="-342900">
-              <a:spcAft>
-                <a:spcPts val="600"/>
-              </a:spcAft>
-              <a:buSzPct val="100000"/>
-              <a:buChar char="•"/>
-            </a:pPr>
-            <a:r>
-              <a:rPr lang="en-US" sz="950" dirty="0">
-                <a:solidFill>
-                  <a:srgbClr val="1E293B"/>
+              <a:t>No significant difference between sectors. When the Central Bank moves or the pound drops, every sector feels it equally.</a:t>
+            </a:r>
+            <a:endParaRPr lang="en-US" sz="1050" dirty="0"/>
+          </a:p>
+        </p:txBody>
+      </p:sp>
+      <p:sp>
+        <p:nvSpPr>
+          <p:cNvPr id="16" name="Shape 14"/>
+          <p:cNvSpPr/>
+          <p:nvPr/>
+        </p:nvSpPr>
+        <p:spPr>
+          <a:xfrm>
+            <a:off x="457200" y="2697480"/>
+            <a:ext cx="8229600" cy="777240"/>
+          </a:xfrm>
+          <a:prstGeom prst="rect">
+            <a:avLst/>
+          </a:prstGeom>
+          <a:solidFill>
+            <a:srgbClr val="0D2847"/>
+          </a:solidFill>
+          <a:ln/>
+        </p:spPr>
+        <p:txBody>
+          <a:bodyPr/>
+          <a:lstStyle/>
+          <a:p>
+            <a:endParaRPr lang="en-GB"/>
+          </a:p>
+        </p:txBody>
+      </p:sp>
+      <p:sp>
+        <p:nvSpPr>
+          <p:cNvPr id="17" name="Shape 15"/>
+          <p:cNvSpPr/>
+          <p:nvPr/>
+        </p:nvSpPr>
+        <p:spPr>
+          <a:xfrm>
+            <a:off x="457200" y="2697480"/>
+            <a:ext cx="54864" cy="777240"/>
+          </a:xfrm>
+          <a:prstGeom prst="rect">
+            <a:avLst/>
+          </a:prstGeom>
+          <a:solidFill>
+            <a:srgbClr val="EF4444"/>
+          </a:solidFill>
+          <a:ln/>
+        </p:spPr>
+        <p:txBody>
+          <a:bodyPr/>
+          <a:lstStyle/>
+          <a:p>
+            <a:endParaRPr lang="en-GB"/>
+          </a:p>
+        </p:txBody>
+      </p:sp>
+      <p:sp>
+        <p:nvSpPr>
+          <p:cNvPr id="18" name="Shape 16"/>
+          <p:cNvSpPr/>
+          <p:nvPr/>
+        </p:nvSpPr>
+        <p:spPr>
+          <a:xfrm>
+            <a:off x="640080" y="2807208"/>
+            <a:ext cx="347472" cy="347472"/>
+          </a:xfrm>
+          <a:prstGeom prst="ellipse">
+            <a:avLst/>
+          </a:prstGeom>
+          <a:solidFill>
+            <a:srgbClr val="EF4444"/>
+          </a:solidFill>
+          <a:ln/>
+        </p:spPr>
+        <p:txBody>
+          <a:bodyPr/>
+          <a:lstStyle/>
+          <a:p>
+            <a:endParaRPr lang="en-GB"/>
+          </a:p>
+        </p:txBody>
+      </p:sp>
+      <p:sp>
+        <p:nvSpPr>
+          <p:cNvPr id="19" name="Text 17"/>
+          <p:cNvSpPr/>
+          <p:nvPr/>
+        </p:nvSpPr>
+        <p:spPr>
+          <a:xfrm>
+            <a:off x="640080" y="2807208"/>
+            <a:ext cx="347472" cy="347472"/>
+          </a:xfrm>
+          <a:prstGeom prst="rect">
+            <a:avLst/>
+          </a:prstGeom>
+          <a:noFill/>
+          <a:ln/>
+        </p:spPr>
+        <p:txBody>
+          <a:bodyPr wrap="square" lIns="0" tIns="0" rIns="0" bIns="0" rtlCol="0" anchor="ctr"/>
+          <a:lstStyle/>
+          <a:p>
+            <a:pPr marL="0" indent="0" algn="ctr">
+              <a:buNone/>
+            </a:pPr>
+            <a:r>
+              <a:rPr lang="en-US" sz="1500" b="1" dirty="0">
+                <a:solidFill>
+                  <a:srgbClr val="FFFFFF"/>
+                </a:solidFill>
+                <a:latin typeface="Trebuchet MS" pitchFamily="34" charset="0"/>
+                <a:ea typeface="Trebuchet MS" pitchFamily="34" charset="-122"/>
+                <a:cs typeface="Trebuchet MS" pitchFamily="34" charset="-120"/>
+              </a:rPr>
+              <a:t>3</a:t>
+            </a:r>
+            <a:endParaRPr lang="en-US" sz="1500" dirty="0"/>
+          </a:p>
+        </p:txBody>
+      </p:sp>
+      <p:sp>
+        <p:nvSpPr>
+          <p:cNvPr id="20" name="Text 18"/>
+          <p:cNvSpPr/>
+          <p:nvPr/>
+        </p:nvSpPr>
+        <p:spPr>
+          <a:xfrm>
+            <a:off x="1143000" y="2761488"/>
+            <a:ext cx="7315200" cy="274320"/>
+          </a:xfrm>
+          <a:prstGeom prst="rect">
+            <a:avLst/>
+          </a:prstGeom>
+          <a:noFill/>
+          <a:ln/>
+        </p:spPr>
+        <p:txBody>
+          <a:bodyPr wrap="square" lIns="0" tIns="0" rIns="0" bIns="0" rtlCol="0" anchor="ctr"/>
+          <a:lstStyle/>
+          <a:p>
+            <a:pPr marL="0" indent="0">
+              <a:buNone/>
+            </a:pPr>
+            <a:r>
+              <a:rPr lang="en-US" sz="1400" b="1" dirty="0">
+                <a:solidFill>
+                  <a:srgbClr val="EF4444"/>
+                </a:solidFill>
+                <a:latin typeface="Trebuchet MS" pitchFamily="34" charset="0"/>
+                <a:ea typeface="Trebuchet MS" pitchFamily="34" charset="-122"/>
+                <a:cs typeface="Trebuchet MS" pitchFamily="34" charset="-120"/>
+              </a:rPr>
+              <a:t>Devaluations hit everyone</a:t>
+            </a:r>
+            <a:endParaRPr lang="en-US" sz="1400" dirty="0"/>
+          </a:p>
+        </p:txBody>
+      </p:sp>
+      <p:sp>
+        <p:nvSpPr>
+          <p:cNvPr id="21" name="Text 19"/>
+          <p:cNvSpPr/>
+          <p:nvPr/>
+        </p:nvSpPr>
+        <p:spPr>
+          <a:xfrm>
+            <a:off x="1143000" y="3063240"/>
+            <a:ext cx="7315200" cy="365760"/>
+          </a:xfrm>
+          <a:prstGeom prst="rect">
+            <a:avLst/>
+          </a:prstGeom>
+          <a:noFill/>
+          <a:ln/>
+        </p:spPr>
+        <p:txBody>
+          <a:bodyPr wrap="square" lIns="0" tIns="0" rIns="0" bIns="0" rtlCol="0" anchor="ctr"/>
+          <a:lstStyle/>
+          <a:p>
+            <a:pPr marL="0" indent="0">
+              <a:buNone/>
+            </a:pPr>
+            <a:r>
+              <a:rPr lang="en-US" sz="1050" dirty="0">
+                <a:solidFill>
+                  <a:srgbClr val="E2E8F0"/>
                 </a:solidFill>
                 <a:latin typeface="Calibri" pitchFamily="34" charset="0"/>
                 <a:ea typeface="Calibri" pitchFamily="34" charset="-122"/>
                 <a:cs typeface="Calibri" pitchFamily="34" charset="-120"/>
               </a:rPr>
-              <a:t>RMSE tells the real story, error is bigger for expensive stocks (COMI, SWDY)</a:t>
-            </a:r>
-            <a:endParaRPr lang="en-US" sz="950" dirty="0"/>
-          </a:p>
-          <a:p>
-            <a:pPr marL="342900" indent="-342900">
-              <a:spcAft>
-                <a:spcPts val="600"/>
-              </a:spcAft>
-              <a:buSzPct val="100000"/>
-              <a:buChar char="•"/>
-            </a:pPr>
-            <a:r>
-              <a:rPr lang="en-US" sz="950" dirty="0">
-                <a:solidFill>
-                  <a:srgbClr val="1E293B"/>
+              <a:t>All three EGP devaluations caused volatility spikes across all stocks. Jan 2024 was the biggest shock, daily swings doubled overnight.</a:t>
+            </a:r>
+            <a:endParaRPr lang="en-US" sz="1050" dirty="0"/>
+          </a:p>
+        </p:txBody>
+      </p:sp>
+      <p:sp>
+        <p:nvSpPr>
+          <p:cNvPr id="22" name="Shape 20"/>
+          <p:cNvSpPr/>
+          <p:nvPr/>
+        </p:nvSpPr>
+        <p:spPr>
+          <a:xfrm>
+            <a:off x="457200" y="3611880"/>
+            <a:ext cx="8229600" cy="777240"/>
+          </a:xfrm>
+          <a:prstGeom prst="rect">
+            <a:avLst/>
+          </a:prstGeom>
+          <a:solidFill>
+            <a:srgbClr val="0D2847"/>
+          </a:solidFill>
+          <a:ln/>
+        </p:spPr>
+        <p:txBody>
+          <a:bodyPr/>
+          <a:lstStyle/>
+          <a:p>
+            <a:endParaRPr lang="en-GB"/>
+          </a:p>
+        </p:txBody>
+      </p:sp>
+      <p:sp>
+        <p:nvSpPr>
+          <p:cNvPr id="23" name="Shape 21"/>
+          <p:cNvSpPr/>
+          <p:nvPr/>
+        </p:nvSpPr>
+        <p:spPr>
+          <a:xfrm>
+            <a:off x="457200" y="3611880"/>
+            <a:ext cx="54864" cy="777240"/>
+          </a:xfrm>
+          <a:prstGeom prst="rect">
+            <a:avLst/>
+          </a:prstGeom>
+          <a:solidFill>
+            <a:srgbClr val="F59E0B"/>
+          </a:solidFill>
+          <a:ln/>
+        </p:spPr>
+        <p:txBody>
+          <a:bodyPr/>
+          <a:lstStyle/>
+          <a:p>
+            <a:endParaRPr lang="en-GB"/>
+          </a:p>
+        </p:txBody>
+      </p:sp>
+      <p:sp>
+        <p:nvSpPr>
+          <p:cNvPr id="24" name="Shape 22"/>
+          <p:cNvSpPr/>
+          <p:nvPr/>
+        </p:nvSpPr>
+        <p:spPr>
+          <a:xfrm>
+            <a:off x="640080" y="3721608"/>
+            <a:ext cx="347472" cy="347472"/>
+          </a:xfrm>
+          <a:prstGeom prst="ellipse">
+            <a:avLst/>
+          </a:prstGeom>
+          <a:solidFill>
+            <a:srgbClr val="F59E0B"/>
+          </a:solidFill>
+          <a:ln/>
+        </p:spPr>
+        <p:txBody>
+          <a:bodyPr/>
+          <a:lstStyle/>
+          <a:p>
+            <a:endParaRPr lang="en-GB"/>
+          </a:p>
+        </p:txBody>
+      </p:sp>
+      <p:sp>
+        <p:nvSpPr>
+          <p:cNvPr id="25" name="Text 23"/>
+          <p:cNvSpPr/>
+          <p:nvPr/>
+        </p:nvSpPr>
+        <p:spPr>
+          <a:xfrm>
+            <a:off x="640080" y="3721608"/>
+            <a:ext cx="347472" cy="347472"/>
+          </a:xfrm>
+          <a:prstGeom prst="rect">
+            <a:avLst/>
+          </a:prstGeom>
+          <a:noFill/>
+          <a:ln/>
+        </p:spPr>
+        <p:txBody>
+          <a:bodyPr wrap="square" lIns="0" tIns="0" rIns="0" bIns="0" rtlCol="0" anchor="ctr"/>
+          <a:lstStyle/>
+          <a:p>
+            <a:pPr marL="0" indent="0" algn="ctr">
+              <a:buNone/>
+            </a:pPr>
+            <a:r>
+              <a:rPr lang="en-US" sz="1500" b="1" dirty="0">
+                <a:solidFill>
+                  <a:srgbClr val="FFFFFF"/>
+                </a:solidFill>
+                <a:latin typeface="Trebuchet MS" pitchFamily="34" charset="0"/>
+                <a:ea typeface="Trebuchet MS" pitchFamily="34" charset="-122"/>
+                <a:cs typeface="Trebuchet MS" pitchFamily="34" charset="-120"/>
+              </a:rPr>
+              <a:t>4</a:t>
+            </a:r>
+            <a:endParaRPr lang="en-US" sz="1500" dirty="0"/>
+          </a:p>
+        </p:txBody>
+      </p:sp>
+      <p:sp>
+        <p:nvSpPr>
+          <p:cNvPr id="26" name="Text 24"/>
+          <p:cNvSpPr/>
+          <p:nvPr/>
+        </p:nvSpPr>
+        <p:spPr>
+          <a:xfrm>
+            <a:off x="1143000" y="3675888"/>
+            <a:ext cx="7315200" cy="274320"/>
+          </a:xfrm>
+          <a:prstGeom prst="rect">
+            <a:avLst/>
+          </a:prstGeom>
+          <a:noFill/>
+          <a:ln/>
+        </p:spPr>
+        <p:txBody>
+          <a:bodyPr wrap="square" lIns="0" tIns="0" rIns="0" bIns="0" rtlCol="0" anchor="ctr"/>
+          <a:lstStyle/>
+          <a:p>
+            <a:pPr marL="0" indent="0">
+              <a:buNone/>
+            </a:pPr>
+            <a:r>
+              <a:rPr lang="en-US" sz="1400" b="1" dirty="0">
+                <a:solidFill>
+                  <a:srgbClr val="F59E0B"/>
+                </a:solidFill>
+                <a:latin typeface="Trebuchet MS" pitchFamily="34" charset="0"/>
+              </a:rPr>
+              <a:t>It’s all about the economy</a:t>
+            </a:r>
+            <a:endParaRPr lang="en-US" sz="1400" dirty="0"/>
+          </a:p>
+        </p:txBody>
+      </p:sp>
+      <p:sp>
+        <p:nvSpPr>
+          <p:cNvPr id="27" name="Text 25"/>
+          <p:cNvSpPr/>
+          <p:nvPr/>
+        </p:nvSpPr>
+        <p:spPr>
+          <a:xfrm>
+            <a:off x="1143000" y="3977640"/>
+            <a:ext cx="7315200" cy="365760"/>
+          </a:xfrm>
+          <a:prstGeom prst="rect">
+            <a:avLst/>
+          </a:prstGeom>
+          <a:noFill/>
+          <a:ln/>
+        </p:spPr>
+        <p:txBody>
+          <a:bodyPr wrap="square" lIns="0" tIns="0" rIns="0" bIns="0" rtlCol="0" anchor="ctr"/>
+          <a:lstStyle/>
+          <a:p>
+            <a:r>
+              <a:rPr lang="en-GB" sz="1050" dirty="0">
+                <a:solidFill>
+                  <a:schemeClr val="bg1"/>
+                </a:solidFill>
+              </a:rPr>
+              <a:t>EGP</a:t>
+            </a:r>
+            <a:r>
+              <a:rPr lang="en-GB" sz="1050" dirty="0"/>
+              <a:t> </a:t>
+            </a:r>
+            <a:r>
+              <a:rPr lang="en-GB" sz="1050" dirty="0">
+                <a:solidFill>
+                  <a:schemeClr val="bg1"/>
+                </a:solidFill>
+              </a:rPr>
+              <a:t>devaluations, inflation, and Central Bank policy are the real drivers, they explain both why stocks grew and why they all grew together.</a:t>
+            </a:r>
+            <a:endParaRPr lang="en-US" sz="1050" dirty="0">
+              <a:solidFill>
+                <a:schemeClr val="bg1"/>
+              </a:solidFill>
+            </a:endParaRPr>
+          </a:p>
+        </p:txBody>
+      </p:sp>
+      <p:sp>
+        <p:nvSpPr>
+          <p:cNvPr id="28" name="Text 26"/>
+          <p:cNvSpPr/>
+          <p:nvPr/>
+        </p:nvSpPr>
+        <p:spPr>
+          <a:xfrm>
+            <a:off x="457200" y="4498848"/>
+            <a:ext cx="8306114" cy="521208"/>
+          </a:xfrm>
+          <a:prstGeom prst="rect">
+            <a:avLst/>
+          </a:prstGeom>
+          <a:noFill/>
+          <a:ln/>
+        </p:spPr>
+        <p:txBody>
+          <a:bodyPr wrap="square" lIns="0" tIns="0" rIns="0" bIns="0" rtlCol="0" anchor="ctr"/>
+          <a:lstStyle/>
+          <a:p>
+            <a:pPr marL="0" indent="0">
+              <a:buNone/>
+            </a:pPr>
+            <a:r>
+              <a:rPr lang="en-US" sz="1000" i="1" dirty="0">
+                <a:solidFill>
+                  <a:schemeClr val="bg1"/>
                 </a:solidFill>
                 <a:latin typeface="Calibri" pitchFamily="34" charset="0"/>
                 <a:ea typeface="Calibri" pitchFamily="34" charset="-122"/>
                 <a:cs typeface="Calibri" pitchFamily="34" charset="-120"/>
               </a:rPr>
-              <a:t>It's a useful baseline, but real prediction needs news data, volume shocks, and non-linear models</a:t>
-            </a:r>
-            <a:endParaRPr lang="en-US" sz="950" dirty="0"/>
+              <a:t>Bottom line: understanding macro events - especially currency policy - matters more than any technical indicator for navigating the Egyptian market.</a:t>
+            </a:r>
+            <a:endParaRPr lang="en-US" sz="1000" dirty="0">
+              <a:solidFill>
+                <a:schemeClr val="bg1"/>
+              </a:solidFill>
+            </a:endParaRPr>
           </a:p>
         </p:txBody>
       </p:sp>

</xml_diff>